<commit_message>
PowerPoint deck uses Roboto, the app font
Co-Authored-By: Claude Opus 5.5 <noreply@anthropic.com>
Claude-Session: https://claude.ai/code/session_01KjUvAUi5M936k8QYighm28
</commit_message>
<xml_diff>
--- a/slides/oma-dlya-doma.pptx
+++ b/slides/oma-dlya-doma.pptx
@@ -113,37 +113,37 @@
   <p:extLst>
     <p:ext uri="{521415D9-36F7-43E2-AB2F-B90AF26B5E84}">
       <p14:sectionLst xmlns:p14="http://schemas.microsoft.com/office/powerpoint/2010/main">
-        <p14:section name="Вступление" id="{15a47cbb-6572-ed86-ea0c-d5aaa11ca35e}">
+        <p14:section name="Вступление" id="{c94557f7-1c26-65a6-84a8-4637b65e939c}">
           <p14:sldIdLst>
             <p14:sldId id="256"/>
           </p14:sldIdLst>
         </p14:section>
-        <p14:section name="Проблема" id="{6c38b86c-ae79-ee27-fa5d-e4d1b87b6295}">
+        <p14:section name="Проблема" id="{858b9970-8ecb-9748-2539-d0f0b2634c46}">
           <p14:sldIdLst>
             <p14:sldId id="257"/>
           </p14:sldIdLst>
         </p14:section>
-        <p14:section name="Решение" id="{5dd402c4-db70-b558-df9a-de3d18d01c76}">
+        <p14:section name="Решение" id="{a83f47cd-26fb-b421-ac77-b2a6e99ef024}">
           <p14:sldIdLst>
             <p14:sldId id="258"/>
           </p14:sldIdLst>
         </p14:section>
-        <p14:section name="Конкуренты" id="{2baae260-96ef-6951-c814-c06782b9dc19}">
+        <p14:section name="Конкуренты" id="{d0ddbe83-230a-5bf0-7462-51a282bf289d}">
           <p14:sldIdLst>
             <p14:sldId id="259"/>
           </p14:sldIdLst>
         </p14:section>
-        <p14:section name="Путь пользователя" id="{4fa848e6-d78f-7af0-11ec-fc977205f31c}">
+        <p14:section name="Путь пользователя" id="{0c898252-5465-9f7f-0e85-2db5b2015de0}">
           <p14:sldIdLst>
             <p14:sldId id="260"/>
           </p14:sldIdLst>
         </p14:section>
-        <p14:section name="Демо" id="{058f2f0c-9171-a5be-6229-e0796f0ff818}">
+        <p14:section name="Демо" id="{1ee5dd13-f0e4-9ebe-0549-db73bb02233a}">
           <p14:sldIdLst>
             <p14:sldId id="261"/>
           </p14:sldIdLst>
         </p14:section>
-        <p14:section name="Экономика" id="{1a7dd056-2245-4eb2-d2a2-44cd09764c82}">
+        <p14:section name="Экономика" id="{9b85de67-18a2-3d53-f9d9-3536fc3af8af}">
           <p14:sldIdLst>
             <p14:sldId id="262"/>
           </p14:sldIdLst>
@@ -10123,7 +10123,7 @@
     </a:clrScheme>
     <a:fontScheme name="OMA dlya doma">
       <a:majorFont>
-        <a:latin typeface="Arial"/>
+        <a:latin typeface="Roboto"/>
         <a:ea typeface=""/>
         <a:cs typeface=""/>
         <a:font script="Jpan" typeface="游ゴシック Light"/>
@@ -10175,7 +10175,7 @@
         <a:font script="Tfng" typeface="Ebrima"/>
       </a:majorFont>
       <a:minorFont>
-        <a:latin typeface="Arial"/>
+        <a:latin typeface="Roboto"/>
         <a:ea typeface=""/>
         <a:cs typeface=""/>
         <a:font script="Jpan" typeface="游ゴシック"/>

</xml_diff>